<commit_message>
Adiciona link do GitHub aos slides e roteiro de apresentacao
- Slides 1 e 8: bloco com o repositorio do projeto
- Roteiro reescrito para gravacao em video (narracao + gravacao de tela)
- Regenera o PDF da apresentacao a partir do pptx atualizado
</commit_message>
<xml_diff>
--- a/doc/atividade-3/Apresentacao_Atividade_3_Sistema_Veiculos.pptx
+++ b/doc/atividade-3/Apresentacao_Atividade_3_Sistema_Veiculos.pptx
@@ -2,20 +2,20 @@
 <file path=ppt/presentation.xml><?xml version="1.0" encoding="utf-8"?>
 <p:presentation xmlns:p="http://schemas.openxmlformats.org/presentationml/2006/main">
   <p:sldMasterIdLst>
-    <p:sldMasterId xmlns:r="http://schemas.openxmlformats.org/officeDocument/2006/relationships" id="2147483648" r:id="R82d872816d494938"/>
+    <p:sldMasterId xmlns:r="http://schemas.openxmlformats.org/officeDocument/2006/relationships" id="2147483648" r:id="R84e9747d00dd42b6"/>
   </p:sldMasterIdLst>
   <p:notesMasterIdLst>
-    <p:notesMasterId xmlns:r="http://schemas.openxmlformats.org/officeDocument/2006/relationships" r:id="Re0d1c20f485e48aa"/>
+    <p:notesMasterId xmlns:r="http://schemas.openxmlformats.org/officeDocument/2006/relationships" r:id="R15b0367ce7d74024"/>
   </p:notesMasterIdLst>
   <p:sldIdLst>
-    <p:sldId xmlns:r="http://schemas.openxmlformats.org/officeDocument/2006/relationships" id="256" r:id="Rdd323d1216d6445d"/>
-    <p:sldId xmlns:r="http://schemas.openxmlformats.org/officeDocument/2006/relationships" id="257" r:id="Refbd19e7b4d04c1b"/>
-    <p:sldId xmlns:r="http://schemas.openxmlformats.org/officeDocument/2006/relationships" id="258" r:id="R3f25d50242444e9a"/>
-    <p:sldId xmlns:r="http://schemas.openxmlformats.org/officeDocument/2006/relationships" id="259" r:id="R8d42c1fee3db4763"/>
-    <p:sldId xmlns:r="http://schemas.openxmlformats.org/officeDocument/2006/relationships" id="260" r:id="Rd1a2de89132f48d6"/>
-    <p:sldId xmlns:r="http://schemas.openxmlformats.org/officeDocument/2006/relationships" id="261" r:id="R9e063c8b118d4fa9"/>
-    <p:sldId xmlns:r="http://schemas.openxmlformats.org/officeDocument/2006/relationships" id="262" r:id="R16eec0107570410c"/>
-    <p:sldId xmlns:r="http://schemas.openxmlformats.org/officeDocument/2006/relationships" id="263" r:id="R77a77d7ad9d94029"/>
+    <p:sldId xmlns:r="http://schemas.openxmlformats.org/officeDocument/2006/relationships" id="256" r:id="Rb6fe51177db04e5d"/>
+    <p:sldId xmlns:r="http://schemas.openxmlformats.org/officeDocument/2006/relationships" id="257" r:id="R229b95a884a648e2"/>
+    <p:sldId xmlns:r="http://schemas.openxmlformats.org/officeDocument/2006/relationships" id="258" r:id="R64846c0ec3f84c10"/>
+    <p:sldId xmlns:r="http://schemas.openxmlformats.org/officeDocument/2006/relationships" id="259" r:id="R2c9f8153170d41c9"/>
+    <p:sldId xmlns:r="http://schemas.openxmlformats.org/officeDocument/2006/relationships" id="260" r:id="R0b2b87564834469b"/>
+    <p:sldId xmlns:r="http://schemas.openxmlformats.org/officeDocument/2006/relationships" id="261" r:id="R1bb954e7a44945c0"/>
+    <p:sldId xmlns:r="http://schemas.openxmlformats.org/officeDocument/2006/relationships" id="262" r:id="Rce2c2d7e7b794b71"/>
+    <p:sldId xmlns:r="http://schemas.openxmlformats.org/officeDocument/2006/relationships" id="263" r:id="R1c8ad9f593814c45"/>
   </p:sldIdLst>
   <p:sldSz cx="12192000" cy="6858000"/>
   <p:notesSz cx="6858000" cy="9144000"/>
@@ -1024,7 +1024,7 @@
   </p:cSld>
   <p:clrMap bg1="lt1" tx1="dk1" bg2="lt2" tx2="dk2" accent1="accent1" accent2="accent2" accent3="accent3" accent4="accent4" accent5="accent5" accent6="accent6" hlink="hlink" folHlink="folHlink"/>
   <p:sldLayoutIdLst>
-    <p:sldLayoutId xmlns:r="http://schemas.openxmlformats.org/officeDocument/2006/relationships" id="2147483649" r:id="R299fb1c8c5f447c6"/>
+    <p:sldLayoutId xmlns:r="http://schemas.openxmlformats.org/officeDocument/2006/relationships" id="2147483649" r:id="R40712da902f8423d"/>
   </p:sldLayoutIdLst>
   <p:txStyles>
     <p:titleStyle>
@@ -1659,7 +1659,7 @@
                 <a:ea typeface="Aptos"/>
                 <a:cs typeface="Aptos"/>
               </a:rPr>
-              <a:t>MVP funcional para controle de acesso</a:t>
+              <a:t>Sistema para controle de veículos</a:t>
             </a:r>
           </a:p>
         </p:txBody>
@@ -1724,7 +1724,7 @@
                 <a:ea typeface="Aptos"/>
                 <a:cs typeface="Aptos"/>
               </a:rPr>
-              <a:t>Da modelagem ao protótipo</a:t>
+              <a:t>Da ideia ao sistema</a:t>
             </a:r>
           </a:p>
         </p:txBody>
@@ -2147,7 +2147,7 @@
                 <a:ea typeface="Aptos"/>
                 <a:cs typeface="Aptos"/>
               </a:rPr>
-              <a:t>Mostrar o problema, a solução e o MVP em funcionamento.</a:t>
+              <a:t>Mostrar o problema, a solução e o sistema funcionando.</a:t>
             </a:r>
           </a:p>
         </p:txBody>
@@ -2313,6 +2313,89 @@
                 <a:cs typeface="Aptos"/>
               </a:rPr>
               <a:t>01</a:t>
+            </a:r>
+          </a:p>
+        </p:txBody>
+      </p:sp>
+      <p:sp xmlns:a="http://schemas.openxmlformats.org/drawingml/2006/main">
+        <p:nvSpPr>
+          <p:cNvPr id="18" name=""/>
+          <p:cNvSpPr>
+            <a:spLocks noGrp="1"/>
+          </p:cNvSpPr>
+          <p:nvPr/>
+        </p:nvSpPr>
+        <p:spPr>
+          <a:xfrm>
+            <a:off x="609600" y="5334000"/>
+            <a:ext cx="4200000" cy="762000"/>
+          </a:xfrm>
+          <a:prstGeom prst="rect">
+            <a:avLst/>
+          </a:prstGeom>
+          <a:solidFill>
+            <a:srgbClr val="000000">
+              <a:alpha val="0"/>
+            </a:srgbClr>
+          </a:solidFill>
+          <a:ln w="0">
+            <a:solidFill>
+              <a:srgbClr val="000000">
+                <a:alpha val="0"/>
+              </a:srgbClr>
+            </a:solidFill>
+            <a:prstDash val="solid"/>
+          </a:ln>
+        </p:spPr>
+        <p:txBody>
+          <a:bodyPr lIns="0" tIns="0" rIns="0" bIns="0" anchor="t"/>
+          <a:lstStyle/>
+          <a:p>
+            <a:pPr algn="l">
+              <a:buNone/>
+            </a:pPr>
+            <a:r>
+              <a:rPr sz="900" b="1">
+                <a:solidFill>
+                  <a:srgbClr val="C8D9E5"/>
+                </a:solidFill>
+                <a:latin typeface="Aptos"/>
+                <a:ea typeface="Aptos"/>
+                <a:cs typeface="Aptos"/>
+              </a:rPr>
+              <a:t>REPOSITÓRIO NO GITHUB</a:t>
+            </a:r>
+          </a:p>
+          <a:p>
+            <a:pPr algn="l">
+              <a:buNone/>
+            </a:pPr>
+            <a:r>
+              <a:rPr sz="1050" b="1">
+                <a:solidFill>
+                  <a:srgbClr val="FFFFFF"/>
+                </a:solidFill>
+                <a:latin typeface="Aptos"/>
+                <a:ea typeface="Aptos"/>
+                <a:cs typeface="Aptos"/>
+              </a:rPr>
+              <a:t>github.com/rafaeldreyer/</a:t>
+            </a:r>
+          </a:p>
+          <a:p>
+            <a:pPr algn="l">
+              <a:buNone/>
+            </a:pPr>
+            <a:r>
+              <a:rPr sz="1050" b="1">
+                <a:solidFill>
+                  <a:srgbClr val="FFFFFF"/>
+                </a:solidFill>
+                <a:latin typeface="Aptos"/>
+                <a:ea typeface="Aptos"/>
+                <a:cs typeface="Aptos"/>
+              </a:rPr>
+              <a:t>sistema-entrada-saida-veiculos</a:t>
             </a:r>
           </a:p>
         </p:txBody>
@@ -2532,7 +2615,7 @@
                 <a:ea typeface="Aptos"/>
                 <a:cs typeface="Aptos"/>
               </a:rPr>
-              <a:t>Registros fragmentados escondem quem ainda está no local.</a:t>
+              <a:t>Registros em lugares diferentes dificultam o controle.</a:t>
             </a:r>
           </a:p>
         </p:txBody>
@@ -2926,7 +3009,7 @@
                 <a:ea typeface="Aptos"/>
                 <a:cs typeface="Aptos"/>
               </a:rPr>
-              <a:t>Placas e responsáveis dispersos</a:t>
+              <a:t>Placas e responsáveis em locais diferentes</a:t>
             </a:r>
           </a:p>
         </p:txBody>
@@ -3122,7 +3205,7 @@
                 <a:ea typeface="Aptos"/>
                 <a:cs typeface="Aptos"/>
               </a:rPr>
-              <a:t>EFEITO OPERACIONAL</a:t>
+              <a:t>CONSEQUÊNCIA</a:t>
             </a:r>
           </a:p>
         </p:txBody>
@@ -3187,7 +3270,7 @@
                 <a:ea typeface="Aptos"/>
                 <a:cs typeface="Aptos"/>
               </a:rPr>
-              <a:t>A equipe perde tempo para responder perguntas simples.</a:t>
+              <a:t>A consulta das informações fica mais demorada.</a:t>
             </a:r>
           </a:p>
         </p:txBody>
@@ -3685,7 +3768,7 @@
                 <a:ea typeface="Aptos"/>
                 <a:cs typeface="Aptos"/>
               </a:rPr>
-              <a:t>Um único fluxo conecta cadastro, movimentação e consulta.</a:t>
+              <a:t>O sistema reúne cadastro, entrada, saída e consulta.</a:t>
             </a:r>
           </a:p>
         </p:txBody>
@@ -4865,7 +4948,7 @@
                 <a:ea typeface="Aptos"/>
                 <a:cs typeface="Aptos"/>
               </a:rPr>
-              <a:t>A mesma base informa veículos presentes, vagas ocupadas e histórico.</a:t>
+              <a:t>O sistema mostra os veículos presentes, as vagas ocupadas e os registros anteriores.</a:t>
             </a:r>
           </a:p>
         </p:txBody>
@@ -5250,7 +5333,7 @@
                 <a:ea typeface="Aptos"/>
                 <a:cs typeface="Aptos"/>
               </a:rPr>
-              <a:t>Seis tabelas sustentam o fluxo sem duplicar informações.</a:t>
+              <a:t>O banco possui seis tabelas relacionadas.</a:t>
             </a:r>
           </a:p>
         </p:txBody>
@@ -7116,7 +7199,7 @@
                 <a:ea typeface="Aptos"/>
                 <a:cs typeface="Aptos"/>
               </a:rPr>
-              <a:t>REGRA CENTRAL</a:t>
+              <a:t>REGRA PRINCIPAL</a:t>
             </a:r>
           </a:p>
         </p:txBody>
@@ -7181,7 +7264,7 @@
                 <a:ea typeface="Aptos"/>
                 <a:cs typeface="Aptos"/>
               </a:rPr>
-              <a:t>Uma entrada fica aberta até receber data e usuário de saída.</a:t>
+              <a:t>A entrada fica aberta até o veículo sair.</a:t>
             </a:r>
           </a:p>
         </p:txBody>
@@ -7566,7 +7649,7 @@
                 <a:ea typeface="Aptos"/>
                 <a:cs typeface="Aptos"/>
               </a:rPr>
-              <a:t>Administrador e porteiro compartilham o fluxo operacional.</a:t>
+              <a:t>Administrador e porteiro usam as funções do sistema.</a:t>
             </a:r>
           </a:p>
         </p:txBody>
@@ -7729,7 +7812,7 @@
                 <a:ea typeface="Aptos"/>
                 <a:cs typeface="Aptos"/>
               </a:rPr>
-              <a:t>cadastros + operação</a:t>
+              <a:t>cadastros e operações</a:t>
             </a:r>
           </a:p>
         </p:txBody>
@@ -7892,7 +7975,7 @@
                 <a:ea typeface="Aptos"/>
                 <a:cs typeface="Aptos"/>
               </a:rPr>
-              <a:t>operação diária</a:t>
+              <a:t>uso diário</a:t>
             </a:r>
           </a:p>
         </p:txBody>
@@ -9092,7 +9175,7 @@
                 <a:ea typeface="Aptos"/>
                 <a:cs typeface="Aptos"/>
               </a:rPr>
-              <a:t>O CRUD de veículos inclui cadastrar, listar, visualizar, editar e excluir.</a:t>
+              <a:t>O cadastro de veículos permite incluir, consultar, editar e excluir.</a:t>
             </a:r>
           </a:p>
         </p:txBody>
@@ -9477,7 +9560,7 @@
                 <a:ea typeface="Aptos"/>
                 <a:cs typeface="Aptos"/>
               </a:rPr>
-              <a:t>Agora o fluxo completo será executado no sistema.</a:t>
+              <a:t>Agora será feita uma demonstração do sistema.</a:t>
             </a:r>
           </a:p>
         </p:txBody>
@@ -9524,7 +9607,7 @@
           <p:nvPr/>
         </p:nvPicPr>
         <p:blipFill>
-          <a:blip xmlns:r="http://schemas.openxmlformats.org/officeDocument/2006/relationships" xmlns:a="http://schemas.openxmlformats.org/drawingml/2006/main" r:embed="Rbc455185d65e4710"/>
+          <a:blip xmlns:r="http://schemas.openxmlformats.org/officeDocument/2006/relationships" xmlns:a="http://schemas.openxmlformats.org/drawingml/2006/main" r:embed="R585647f1123b430e"/>
           <a:stretch xmlns:a="http://schemas.openxmlformats.org/drawingml/2006/main"/>
         </p:blipFill>
         <p:spPr>
@@ -9630,7 +9713,7 @@
                 <a:ea typeface="Aptos"/>
                 <a:cs typeface="Aptos"/>
               </a:rPr>
-              <a:t>ROTEIRO • 5 MIN</a:t>
+              <a:t>DEMONSTRAÇÃO • 5 MIN</a:t>
             </a:r>
           </a:p>
         </p:txBody>
@@ -9825,7 +9908,7 @@
                 <a:ea typeface="Aptos"/>
                 <a:cs typeface="Aptos"/>
               </a:rPr>
-              <a:t>3  CRUD de veículo</a:t>
+              <a:t>3  Cadastro de veículo</a:t>
             </a:r>
           </a:p>
         </p:txBody>
@@ -10470,7 +10553,7 @@
                 <a:ea typeface="Aptos"/>
                 <a:cs typeface="Aptos"/>
               </a:rPr>
-              <a:t>O MVP cobre o controle essencial e deixa uma evolução clara.</a:t>
+              <a:t>O sistema atende às principais funções do projeto.</a:t>
             </a:r>
           </a:p>
         </p:txBody>
@@ -10930,7 +11013,7 @@
                 <a:ea typeface="Aptos"/>
                 <a:cs typeface="Aptos"/>
               </a:rPr>
-              <a:t>testes manuais registrados</a:t>
+              <a:t>testes manuais realizados</a:t>
             </a:r>
           </a:p>
         </p:txBody>
@@ -11028,7 +11111,7 @@
                 <a:ea typeface="Aptos"/>
                 <a:cs typeface="Aptos"/>
               </a:rPr>
-              <a:t>ENTREGUE</a:t>
+              <a:t>FUNÇÕES</a:t>
             </a:r>
           </a:p>
         </p:txBody>
@@ -11093,7 +11176,7 @@
                 <a:ea typeface="Aptos"/>
                 <a:cs typeface="Aptos"/>
               </a:rPr>
-              <a:t>Login • painel • CRUD • movimentações • consulta • contato</a:t>
+              <a:t>Login • página principal • cadastro • entrada • saída • consulta • contato</a:t>
             </a:r>
           </a:p>
         </p:txBody>
@@ -11280,7 +11363,7 @@
                 <a:ea typeface="Aptos"/>
                 <a:cs typeface="Aptos"/>
               </a:rPr>
-              <a:t>CRUD completo dos cadastros auxiliares</a:t>
+              <a:t>Mais opções nos outros cadastros</a:t>
             </a:r>
           </a:p>
           <a:p xmlns:a="http://schemas.openxmlformats.org/drawingml/2006/main">
@@ -11304,7 +11387,7 @@
                 <a:ea typeface="Aptos"/>
                 <a:cs typeface="Aptos"/>
               </a:rPr>
-              <a:t>Perfis e permissões mais detalhados</a:t>
+              <a:t>Diferentes níveis de acesso</a:t>
             </a:r>
           </a:p>
         </p:txBody>
@@ -11984,7 +12067,7 @@
                 <a:ea typeface="Aptos"/>
                 <a:cs typeface="Aptos"/>
               </a:rPr>
-              <a:t>MVP</a:t>
+              <a:t>SISTEMA</a:t>
             </a:r>
           </a:p>
         </p:txBody>
@@ -12049,7 +12132,7 @@
                 <a:ea typeface="Aptos"/>
                 <a:cs typeface="Aptos"/>
               </a:rPr>
-              <a:t>funcional</a:t>
+              <a:t>funcionando</a:t>
             </a:r>
           </a:p>
         </p:txBody>
@@ -12280,6 +12363,73 @@
                 <a:cs typeface="Aptos"/>
               </a:rPr>
               <a:t>08</a:t>
+            </a:r>
+          </a:p>
+        </p:txBody>
+      </p:sp>
+      <p:sp xmlns:a="http://schemas.openxmlformats.org/drawingml/2006/main">
+        <p:nvSpPr>
+          <p:cNvPr id="15" name=""/>
+          <p:cNvSpPr>
+            <a:spLocks noGrp="1"/>
+          </p:cNvSpPr>
+          <p:nvPr/>
+        </p:nvSpPr>
+        <p:spPr>
+          <a:xfrm>
+            <a:off x="609600" y="5100000"/>
+            <a:ext cx="6667500" cy="700000"/>
+          </a:xfrm>
+          <a:prstGeom prst="rect">
+            <a:avLst/>
+          </a:prstGeom>
+          <a:solidFill>
+            <a:srgbClr val="000000">
+              <a:alpha val="0"/>
+            </a:srgbClr>
+          </a:solidFill>
+          <a:ln w="0">
+            <a:solidFill>
+              <a:srgbClr val="000000">
+                <a:alpha val="0"/>
+              </a:srgbClr>
+            </a:solidFill>
+            <a:prstDash val="solid"/>
+          </a:ln>
+        </p:spPr>
+        <p:txBody>
+          <a:bodyPr lIns="0" tIns="0" rIns="0" bIns="0" anchor="t"/>
+          <a:lstStyle/>
+          <a:p>
+            <a:pPr algn="l">
+              <a:buNone/>
+            </a:pPr>
+            <a:r>
+              <a:rPr sz="900" b="1">
+                <a:solidFill>
+                  <a:srgbClr val="BFD0DD"/>
+                </a:solidFill>
+                <a:latin typeface="Aptos"/>
+                <a:ea typeface="Aptos"/>
+                <a:cs typeface="Aptos"/>
+              </a:rPr>
+              <a:t>REPOSITÓRIO NO GITHUB</a:t>
+            </a:r>
+          </a:p>
+          <a:p>
+            <a:pPr algn="l">
+              <a:buNone/>
+            </a:pPr>
+            <a:r>
+              <a:rPr sz="1300" b="1">
+                <a:solidFill>
+                  <a:srgbClr val="D99B3D"/>
+                </a:solidFill>
+                <a:latin typeface="Aptos"/>
+                <a:ea typeface="Aptos"/>
+                <a:cs typeface="Aptos"/>
+              </a:rPr>
+              <a:t>github.com/rafaeldreyer/sistema-entrada-saida-veiculos</a:t>
             </a:r>
           </a:p>
         </p:txBody>

</xml_diff>